<commit_message>
Update code, outputs, tex, and presentation for 02.06.2026 meeting
- Add new analysis scripts (07c-07l, 10c, 16-22, enso/regime/robustness)
- Update all output figures and tables with latest results
- Add tex sections: Abstract, Discussion, Appendix_A, formula_sheet
- Update all existing tex sections with current draft
- Add compiled main.pdf
- Add 09_06_26.pptx presentation

Co-Authored-By: Claude Sonnet 4.6 <noreply@anthropic.com>
</commit_message>
<xml_diff>
--- a/17_03_26_Bleher.pptx
+++ b/17_03_26_Bleher.pptx
@@ -51532,9 +51532,10 @@
           <a:bodyPr/>
           <a:lstStyle/>
           <a:p>
+            <a:pPr algn="ctr"/>
             <a:r>
               <a:rPr lang="de-DE" sz="2800" dirty="0"/>
-              <a:t>RQ 1</a:t>
+              <a:t>1</a:t>
             </a:r>
           </a:p>
         </p:txBody>
@@ -51871,9 +51872,10 @@
           <a:bodyPr/>
           <a:lstStyle/>
           <a:p>
+            <a:pPr algn="ctr"/>
             <a:r>
               <a:rPr lang="de-DE" sz="2800" dirty="0"/>
-              <a:t>RQ 2</a:t>
+              <a:t>2</a:t>
             </a:r>
           </a:p>
         </p:txBody>

</xml_diff>